<commit_message>
Enhance Chapter 6 with detailed conclusions and results from the IDS prototype evaluation. Update accuracy metrics, loss values, and round durations for various model configurations. Add new figures to support findings on model performance, communication overhead, and latency. Consolidate analysis outputs into a unified SRE layer for comprehensive reporting.
</commit_message>
<xml_diff>
--- a/src/Documento_Final/Rev1__Tesis_Sistemas_Uniandes_2/Poster_Tesis_HFL_v7_Uniandes.pptx
+++ b/src/Documento_Final/Rev1__Tesis_Sistemas_Uniandes_2/Poster_Tesis_HFL_v7_Uniandes.pptx
@@ -16835,7 +16835,7 @@
           <a:p>
             <a:r>
               <a:rPr lang="es-CO"/>
-              <a:t>Se disena, implementa y evalua un Sistema de Deteccion de Intrusiones (IDS) para trafico IoT/MQTT desplegado sobre una arquitectura jerarquica Edge-Fog-Cloud (ESP32-S3 + Raspberry Pi 4 + PC). Los nodos edge ejecutan inferencia TinyML sobre 13 features de flujo y publican datos al gateway; el gateway entrena localmente y reporta pesos al PC, que coordina rondas de FedAvg. Todas las comunicaciones MQTT/HTTP se protegen con ASCON-128 (estandar NIST de criptografia ligera). Se comparan cuatro variantes (RN+ASCON, RN sin ASCON, CNN-1D, FOG con lider/peer) y se cuantifica el overhead de seguridad sobre el ciclo federado. Resultados: accuracy global de 0.946 (RN+ASCON) y 0.975 (CNN+FOG), con un overhead temporal de ASCON inferior al 0.1% del tiempo de ronda y un costo de tamano del 36% por mensaje, validando una arquitectura operativa, replicable y segura para IDS IoT.</a:t>
+              <a:t>Se disena, implementa y evalua un Sistema de Deteccion de Intrusiones (IDS) para trafico IoT/MQTT desplegado sobre una arquitectura jerarquica Edge-Fog-Cloud (ESP32-S3 + Raspberry Pi 4 + PC). Los nodos edge ejecutan inferencia TinyML sobre 13 features de flujo y publican datos al gateway; el gateway entrena localmente y reporta pesos al PC, que coordina rondas de FedAvg. Todas las comunicaciones MQTT/HTTP se protegen con ASCON-128 (estandar NIST de criptografia ligera). Se comparan ocho variantes (RN/CNN x ASCON/PLAIN x NoFOG/FOG) sobre 58 intentos y se cuantifica el overhead de seguridad sobre el ciclo federado. Resultados: accuracy global de 0.975 en CNN_ASCON_FOG (mejor configuracion), 0.963 en RN_ASCON_FOG y 0.946 promedio agregado de las 8 variantes. ASCON-128 mejora la accuracy +3.2 puntos respecto al baseline PLAIN (filtrado implicito de mensajes corruptos), con un overhead temporal inferior al 0.27% del tiempo de ronda y un costo de tamano del 48% por mensaje, validando una arquitectura operativa, replicable y segura para IDS IoT.</a:t>
             </a:r>
             <a:endParaRPr lang="es-CO"/>
           </a:p>
@@ -17029,7 +17029,7 @@
           <a:p>
             <a:r>
               <a:rPr lang="es-CO"/>
-              <a:t>Nicolas Camargo</a:t>
+              <a:t>Nicolas Casas Ibarra</a:t>
             </a:r>
             <a:endParaRPr lang="es-CO"/>
           </a:p>
@@ -17052,7 +17052,7 @@
           <a:p>
             <a:r>
               <a:rPr lang="es-CO"/>
-              <a:t>n.camargo@uniandes.edu.co</a:t>
+              <a:t>ni.casas@uniandes.edu.co</a:t>
             </a:r>
             <a:endParaRPr lang="es-CO"/>
           </a:p>
@@ -17290,7 +17290,7 @@
         <p:spPr/>
         <p:txBody>
           <a:bodyPr>
-            <a:normAutofit fontScale="90000" lnSpcReduction="10000"/>
+            <a:normAutofit fontScale="85000" lnSpcReduction="15000"/>
           </a:bodyPr>
           <a:lstStyle/>
           <a:p>
@@ -17304,7 +17304,7 @@
             </a:r>
             <a:r>
               <a:rPr lang="es-CO"/>
-              <a:t>Random Forest 0.9994, SVM-RBF 0.9968 (no caben en MCU); Decision Tree 0.9987 (~15 KB).</a:t>
+              <a:t>Random Forest 0.9994, SVM-RBF 0.9968 (no caben en MCU); Decision Tree 0.9987 (~15 KB); MLP propuesto ~4.5 KB.</a:t>
             </a:r>
           </a:p>
           <a:p>
@@ -17314,11 +17314,11 @@
             </a:pPr>
             <a:r>
               <a:rPr lang="es-CO" b="1"/>
-              <a:t xml:space="preserve">HFL en hardware: </a:t>
+              <a:t xml:space="preserve">8 variantes en hardware (58 intentos): </a:t>
             </a:r>
             <a:r>
               <a:rPr lang="es-CO"/>
-              <a:t>RN+ASCON 0.9463 (loss 0.1415, ronda 61.25 s); RN sin ASCON 0.9298; CNN-1D + FOG + ASCON 0.9750 (loss 0.0910).</a:t>
+              <a:t>CNN_ASCON_FOG 0.9750 (mejor); CNN_ASCON_NoFOG 0.9604; RN_ASCON_FOG 0.9633; RN_ASCON_NoFOG 0.9381; CNN_PLAIN_FOG 0.9444; CNN_PLAIN_NoFOG 0.9389; RN_PLAIN_NoFOG 0.9298; RN_PLAIN_FOG 0.9000.</a:t>
             </a:r>
           </a:p>
           <a:p>
@@ -17328,11 +17328,11 @@
             </a:pPr>
             <a:r>
               <a:rPr lang="es-CO" b="1"/>
-              <a:t xml:space="preserve">Privacidad: </a:t>
+              <a:t xml:space="preserve">ASCON mejora la accuracy: </a:t>
             </a:r>
             <a:r>
               <a:rPr lang="es-CO"/>
-              <a:t>se comparten solo 163 parametros (~652 B) por ronda en lugar de ~13.3 M de valores crudos (reduccion &gt;99.99%).</a:t>
+              <a:t>+3.2 pts promedio frente a PLAIN (0.9592 vs 0.9272). El tag autenticado actua como filtro implicito de mensajes corruptos.</a:t>
             </a:r>
           </a:p>
           <a:p>
@@ -17342,11 +17342,11 @@
             </a:pPr>
             <a:r>
               <a:rPr lang="es-CO" b="1"/>
-              <a:t xml:space="preserve">Overhead ASCON-128: </a:t>
+              <a:t xml:space="preserve">FOG con/sin ASCON: </a:t>
             </a:r>
             <a:r>
               <a:rPr lang="es-CO"/>
-              <a:t>~14 ms por operacion en PC (Python), ~100-300 us en ESP32 (C++). Total ~42 ms por ronda = ~0.06% del ciclo. Tamano: +36% por mensaje (~1.3 KB).</a:t>
+              <a:t>FOG mejora CNN (+1.5 pts ASCON, +0.6 pts PLAIN) y RN+ASCON (+2.5 pts), pero degrada RN_PLAIN_FOG (-3 pts). La integridad de canal habilita la pre-agregacion.</a:t>
             </a:r>
           </a:p>
           <a:p>
@@ -17356,41 +17356,45 @@
             </a:pPr>
             <a:r>
               <a:rPr lang="es-CO" b="1"/>
-              <a:t xml:space="preserve">Convergencia: </a:t>
+              <a:t xml:space="preserve">Privacidad: </a:t>
             </a:r>
             <a:r>
               <a:rPr lang="es-CO"/>
-              <a:t>~20-30 rondas para superar 85% de accuracy; sin degradacion observable al activar ASCON.</a:t>
-            </a:r>
-          </a:p>
-        </p:txBody>
-      </p:sp>
-      <p:sp>
-        <p:nvSpPr>
-          <p:cNvPr id="20" name="19 Conclusiones contenido"/>
-          <p:cNvSpPr>
-            <a:spLocks noGrp="1"/>
-          </p:cNvSpPr>
-          <p:nvPr>
-            <p:ph sz="quarter" idx="39"/>
-          </p:nvPr>
-        </p:nvSpPr>
-        <p:spPr/>
-        <p:txBody>
-          <a:bodyPr>
-            <a:normAutofit fontScale="92500" lnSpcReduction="10000"/>
-          </a:bodyPr>
-          <a:lstStyle/>
+              <a:t>se comparten solo 163 parametros (~652 B) por ronda en lugar de ~13.3 M de valores crudos (reduccion &gt;99.99%).</a:t>
+            </a:r>
+          </a:p>
           <a:p>
             <a:pPr marL="285750" indent="-285750">
               <a:buFont typeface="Arial" panose="020B0604020202020204" pitchFamily="34" charset="0"/>
               <a:buChar char="-"/>
             </a:pPr>
             <a:r>
+              <a:rPr lang="es-CO" b="1"/>
+              <a:t xml:space="preserve">Overhead ASCON-128: </a:t>
+            </a:r>
+            <a:r>
               <a:rPr lang="es-CO"/>
-              <a:t>Un MLP de 4.5 KB en ESP32-S3 detecta trafico MQTT malicioso con accuracy operativa (90-97%) viable para alerta temprana.</a:t>
-            </a:r>
-          </a:p>
+              <a:t>p95 ~4.5 ms en ESP32 (C++) y 25-50 ms en PC (Python). Total 0.10-0.27% del ciclo FL. Tamano: +48% por mensaje (~1.07 KB absolutos).</a:t>
+            </a:r>
+          </a:p>
+        </p:txBody>
+      </p:sp>
+      <p:sp>
+        <p:nvSpPr>
+          <p:cNvPr id="20" name="19 Conclusiones contenido"/>
+          <p:cNvSpPr>
+            <a:spLocks noGrp="1"/>
+          </p:cNvSpPr>
+          <p:nvPr>
+            <p:ph sz="quarter" idx="39"/>
+          </p:nvPr>
+        </p:nvSpPr>
+        <p:spPr/>
+        <p:txBody>
+          <a:bodyPr>
+            <a:normAutofit fontScale="92500" lnSpcReduction="10000"/>
+          </a:bodyPr>
+          <a:lstStyle/>
           <a:p>
             <a:pPr marL="285750" indent="-285750">
               <a:buFont typeface="Arial" panose="020B0604020202020204" pitchFamily="34" charset="0"/>
@@ -17398,7 +17402,7 @@
             </a:pPr>
             <a:r>
               <a:rPr lang="es-CO"/>
-              <a:t>HFL bidireccional reduce &gt;99.99% el intercambio de datos sensibles con una penalizacion de ~7 puntos de accuracy.</a:t>
+              <a:t>TinyML viable: MLP de 4.5 KB y CNN-1D federada en ESP32-S3 alcanzan acc 0.93-0.97 (CNN_ASCON_FOG: 0.975) sobre 58 intentos en hardware real.</a:t>
             </a:r>
           </a:p>
           <a:p>
@@ -17408,7 +17412,7 @@
             </a:pPr>
             <a:r>
               <a:rPr lang="es-CO"/>
-              <a:t>El overhead temporal de ASCON-128 es despreciable (&lt;0.1% del ciclo) y el de tamano (~36% por mensaje) es asumible para redes IoT.</a:t>
+              <a:t>HFL bidireccional reduce &gt;99.99% el intercambio de datos sensibles con una penalizacion de 2-3 puntos en la mejor variante (CNN_ASCON_FOG vs Random Forest).</a:t>
             </a:r>
           </a:p>
           <a:p>
@@ -17418,7 +17422,17 @@
             </a:pPr>
             <a:r>
               <a:rPr lang="es-CO"/>
-              <a:t>El modo FOG con CNN-1D obtiene los mejores resultados (acc 0.975, loss 0.091) sin alterar el contrato bidireccional Edge-Fog-Cloud.</a:t>
+              <a:t>ASCON-128 no solo no degrada: mejora la accuracy +3.2 pts vs PLAIN (filtrado implicito de mensajes corruptos). Overhead: 0.10-0.27% del ciclo y +48% por mensaje.</a:t>
+            </a:r>
+          </a:p>
+          <a:p>
+            <a:pPr marL="285750" indent="-285750">
+              <a:buFont typeface="Arial" panose="020B0604020202020204" pitchFamily="34" charset="0"/>
+              <a:buChar char="-"/>
+            </a:pPr>
+            <a:r>
+              <a:rPr lang="es-CO"/>
+              <a:t>FOG con ASCON gana (+1.5 a +2.5 pts), pero FOG sin ASCON degrada RN (-3 pts): la integridad de canal es condicion habilitante de la pre-agregacion fog.</a:t>
             </a:r>
           </a:p>
           <a:p>

</xml_diff>

<commit_message>
Refactor LaTeX documents and update figures for HFL v7 thesis
- Updated threat model section in Kap3b.tex to include item separation options.
- Adjusted buffer size for training samples from 40 to 30 in multiple sections of Kap3b.tex and Kap5.tex.
- Added new MLP architecture figure (mlp_architecture_figure.png) to Kap3b.tex.
- Enhanced clarity in results and analysis sections of Kap5.tex with consistent formatting.
- Updated PowerPoint poster (Poster_Tesis_HFL_v7_Uniandes.pptx) to reflect recent findings.
- Added compressed Overleaf project files (Tesis_HFL_v7_Overleaf_v4.zip) for easier access.
</commit_message>
<xml_diff>
--- a/src/Documento_Final/Rev1__Tesis_Sistemas_Uniandes_2/Poster_Tesis_HFL_v7_Uniandes.pptx
+++ b/src/Documento_Final/Rev1__Tesis_Sistemas_Uniandes_2/Poster_Tesis_HFL_v7_Uniandes.pptx
@@ -16787,7 +16787,7 @@
           <a:p>
             <a:r>
               <a:rPr lang="es-CO" b="1" dirty="0"/>
-              <a:t>Sistema de Deteccion de Intrusiones IoT/MQTT mediante Aprendizaje Federado Jerarquico (HFL) y Cifrado Ligero ASCON-128 sobre Arquitectura Edge-Fog-Cloud</a:t>
+              <a:t>Sistema de deteccion de intrusiones para redes IoT mediante TinyML, aprendizaje federado jerarquico y cifrado ligero ASCON-128 en una arquitectura Edge-Fog-Cloud</a:t>
             </a:r>
             <a:endParaRPr lang="es-CO" dirty="0"/>
           </a:p>
@@ -16834,8 +16834,8 @@
           <a:lstStyle/>
           <a:p>
             <a:r>
-              <a:rPr lang="es-CO"/>
-              <a:t>Se disena, implementa y evalua un Sistema de Deteccion de Intrusiones (IDS) para trafico IoT/MQTT desplegado sobre una arquitectura jerarquica Edge-Fog-Cloud (ESP32-S3 + Raspberry Pi 4 + PC). Los nodos edge ejecutan inferencia TinyML sobre 13 features de flujo y publican datos al gateway; el gateway entrena localmente y reporta pesos al PC, que coordina rondas de FedAvg. Todas las comunicaciones MQTT/HTTP se protegen con ASCON-128 (estandar NIST de criptografia ligera). Se comparan ocho variantes (RN/CNN x ASCON/PLAIN x NoFOG/FOG) sobre 58 intentos y se cuantifica el overhead de seguridad sobre el ciclo federado. Resultados: accuracy global de 0.975 en CNN_ASCON_FOG (mejor configuracion), 0.963 en RN_ASCON_FOG y 0.946 promedio agregado de las 8 variantes. ASCON-128 mejora la accuracy +3.2 puntos respecto al baseline PLAIN (filtrado implicito de mensajes corruptos), con un overhead temporal inferior al 0.27% del tiempo de ronda y un costo de tamano del 48% por mensaje, validando una arquitectura operativa, replicable y segura para IDS IoT.</a:t>
+              <a:rPr sz="2800" b="0"/>
+              <a:t>Sistema de Deteccion de Intrusiones (IDS) para trafico IoT/MQTT en arquitectura jerarquica Edge-Fog-Cloud (ESP32-S3 + Raspberry Pi 4 + PC). Combina TinyML, HFL bidireccional y ASCON-128 (estandar NIST). Se evaluan 8 variantes (RN/CNN x ASCON/PLAIN x NoFOG/FOG) sobre 58 intentos en hardware real. Mejor resultado: CNN_ASCON_FOG con accuracy 0.975 y loss 0.091.</a:t>
             </a:r>
             <a:endParaRPr lang="es-CO"/>
           </a:p>
@@ -17029,7 +17029,7 @@
           <a:p>
             <a:r>
               <a:rPr lang="es-CO"/>
-              <a:t>Nicolas Casas Ibarra</a:t>
+              <a:t>Santiago Alejandro Jaimes Puerto, Nicolas Casas Ibarra</a:t>
             </a:r>
             <a:endParaRPr lang="es-CO"/>
           </a:p>
@@ -17052,7 +17052,7 @@
           <a:p>
             <a:r>
               <a:rPr lang="es-CO"/>
-              <a:t>ni.casas@uniandes.edu.co</a:t>
+              <a:t>sa.jaimesp@uniandes.edu.co, ni.casas@uniandes.edu.co</a:t>
             </a:r>
             <a:endParaRPr lang="es-CO"/>
           </a:p>
@@ -17075,7 +17075,7 @@
           <a:p>
             <a:r>
               <a:rPr lang="es-CO"/>
-              <a:t>Asesor: &lt;asesor&gt; (&lt;correo asesor&gt;@uniandes.edu.co)</a:t>
+              <a:t>Asesor: Prof. Carlos Andres Lozano Garzon, PhD  (calozanog@uniandes.edu.co)</a:t>
             </a:r>
             <a:endParaRPr lang="es-CO"/>
           </a:p>
@@ -17099,10 +17099,46 @@
           <a:lstStyle/>
           <a:p>
             <a:r>
-              <a:rPr lang="es-CO"/>
-              <a:t>Las redes IoT/IIoT amplian la superficie de ataque pero los IDS clasicos asumen centralizacion de datos, servidores potentes y comunicaciones sin cifrado, supuestos incompatibles con microcontroladores. Se identifican tres brechas: viabilidad de despliegue en MCU, privacidad de datos de trafico y seguridad del ciclo federado. Esta tesis las aborda integrando TinyML, HFL bidireccional y ASCON-128 (estandar NIST de criptografia ligera, 2023) sobre una arquitectura Edge-Fog-Cloud real, evitando el uso de permutaciones ad-hoc previamente comprometidas.</a:t>
+              <a:rPr sz="2800" b="1"/>
+              <a:t>Tres brechas atacadas:</a:t>
             </a:r>
             <a:endParaRPr lang="es-CO"/>
+          </a:p>
+          <a:p>
+            <a:r>
+              <a:rPr sz="2800" b="1"/>
+              <a:t>Viabilidad: </a:t>
+            </a:r>
+            <a:r>
+              <a:rPr sz="2800" b="0"/>
+              <a:t>modelos de alta precision (RF, SVM-RBF) no caben en MCUs.</a:t>
+            </a:r>
+          </a:p>
+          <a:p>
+            <a:r>
+              <a:rPr sz="2800" b="1"/>
+              <a:t>Privacidad: </a:t>
+            </a:r>
+            <a:r>
+              <a:rPr sz="2800" b="0"/>
+              <a:t>centralizar PCAPs es costoso y arriesgado.</a:t>
+            </a:r>
+          </a:p>
+          <a:p>
+            <a:r>
+              <a:rPr sz="2800" b="1"/>
+              <a:t>Seguridad: </a:t>
+            </a:r>
+            <a:r>
+              <a:rPr sz="2800" b="0"/>
+              <a:t>los pesos federados deben protegerse en transito.</a:t>
+            </a:r>
+          </a:p>
+          <a:p>
+            <a:r>
+              <a:rPr sz="2800" b="0"/>
+              <a:t>ASCON-128 (NIST 2023) frente a permutaciones ad-hoc vulnerables.</a:t>
+            </a:r>
           </a:p>
         </p:txBody>
       </p:sp>
@@ -17128,325 +17164,392 @@
               <a:buChar char="-"/>
             </a:pPr>
             <a:r>
-              <a:rPr lang="es-CO"/>
-              <a:t>General: disenar, implementar y evaluar un IDS IoT/MQTT con TinyML, HFL jerarquico y ASCON-128 sobre ESP32-S3, Raspberry Pi 4 y PC.</a:t>
-            </a:r>
-          </a:p>
+              <a:rPr sz="2800" b="1"/>
+              <a:t>General: </a:t>
+            </a:r>
+            <a:r>
+              <a:rPr sz="2800" b="0"/>
+              <a:t>Disenar, implementar y evaluar un IDS IoT/MQTT con TinyML, HFL y ASCON-128.</a:t>
+            </a:r>
+          </a:p>
+          <a:p>
+            <a:r>
+              <a:rPr sz="2800" b="1"/>
+              <a:t>Especificos:</a:t>
+            </a:r>
+          </a:p>
+          <a:p>
+            <a:r>
+              <a:rPr sz="2800" b="0"/>
+              <a:t>- Pipeline de 13 features de flujo, 3 clases (normal, mqtt_bruteforce, scan_A).</a:t>
+            </a:r>
+          </a:p>
+          <a:p>
+            <a:r>
+              <a:rPr sz="2800" b="0"/>
+              <a:t>- Comparar MLP, CNN-1D, Residual MLP y Tiny Transformer.</a:t>
+            </a:r>
+          </a:p>
+          <a:p>
+            <a:r>
+              <a:rPr sz="2800" b="0"/>
+              <a:t>- Implementar HFL bidireccional con/sin ASCON-128.</a:t>
+            </a:r>
+          </a:p>
+          <a:p>
+            <a:r>
+              <a:rPr sz="2800" b="0"/>
+              <a:t>- Evaluar variantes RN, CNN-1D y modo FOG (lider/peer) en hardware.</a:t>
+            </a:r>
+          </a:p>
+        </p:txBody>
+      </p:sp>
+      <p:sp>
+        <p:nvSpPr>
+          <p:cNvPr id="17" name="16 Diseno contenido"/>
+          <p:cNvSpPr>
+            <a:spLocks noGrp="1"/>
+          </p:cNvSpPr>
+          <p:nvPr>
+            <p:ph sz="quarter" idx="36"/>
+          </p:nvPr>
+        </p:nvSpPr>
+        <p:spPr>
+          <a:xfrm>
+            <a:off x="13393663" y="12313568"/>
+            <a:ext cx="11520000" cy="2620859"/>
+          </a:xfrm>
+        </p:spPr>
+        <p:txBody>
+          <a:bodyPr>
+            <a:normAutofit fontScale="90000" lnSpcReduction="10000"/>
+          </a:bodyPr>
+          <a:lstStyle/>
+          <a:p>
+            <a:r>
+              <a:rPr sz="2800" b="1"/>
+              <a:t>Arquitectura Edge / Fog / Cloud:</a:t>
+            </a:r>
+          </a:p>
+          <a:p>
+            <a:r>
+              <a:rPr sz="2800" b="1"/>
+              <a:t>Edge: </a:t>
+            </a:r>
+            <a:r>
+              <a:rPr sz="2800" b="0"/>
+              <a:t>ESP32-S3 -&gt; features + inferencia TinyML.</a:t>
+            </a:r>
+          </a:p>
+          <a:p>
+            <a:r>
+              <a:rPr sz="2800" b="1"/>
+              <a:t>Fog: </a:t>
+            </a:r>
+            <a:r>
+              <a:rPr sz="2800" b="0"/>
+              <a:t>RPi 4 -&gt; broker MQTT + entrenamiento local.</a:t>
+            </a:r>
+          </a:p>
+          <a:p>
+            <a:r>
+              <a:rPr sz="2800" b="1"/>
+              <a:t>Cloud: </a:t>
+            </a:r>
+            <a:r>
+              <a:rPr sz="2800" b="0"/>
+              <a:t>PC -&gt; FastAPI + FedAvg ponderado.</a:t>
+            </a:r>
+          </a:p>
+          <a:p>
+            <a:r>
+              <a:rPr sz="2800" b="1"/>
+              <a:t>FOG: </a:t>
+            </a:r>
+            <a:r>
+              <a:rPr sz="2800" b="0"/>
+              <a:t>leader+peer con fog/weights y fog/global_model.</a:t>
+            </a:r>
+          </a:p>
+          <a:p>
+            <a:r>
+              <a:rPr sz="2800" b="0"/>
+              <a:t>ASCON-128 sobre los 4 canales (envelope JSON).</a:t>
+            </a:r>
+          </a:p>
+        </p:txBody>
+      </p:sp>
+      <p:sp>
+        <p:nvSpPr>
+          <p:cNvPr id="18" name="17 Metodologia contenido"/>
+          <p:cNvSpPr>
+            <a:spLocks noGrp="1"/>
+          </p:cNvSpPr>
+          <p:nvPr>
+            <p:ph sz="quarter" idx="37"/>
+          </p:nvPr>
+        </p:nvSpPr>
+        <p:spPr>
+          <a:xfrm>
+            <a:off x="648247" y="24482970"/>
+            <a:ext cx="11520000" cy="3863199"/>
+          </a:xfrm>
+        </p:spPr>
+        <p:txBody>
+          <a:bodyPr>
+            <a:normAutofit fontScale="92500" lnSpcReduction="10000"/>
+          </a:bodyPr>
+          <a:lstStyle/>
+          <a:p>
+            <a:r>
+              <a:rPr sz="2800" b="1"/>
+              <a:t>Protocolo HFL bidireccional en 3 fases:</a:t>
+            </a:r>
+            <a:endParaRPr lang="es-CO"/>
+          </a:p>
+          <a:p>
+            <a:r>
+              <a:rPr sz="2800" b="1"/>
+              <a:t>1) Top-Down: </a:t>
+            </a:r>
+            <a:r>
+              <a:rPr sz="2800" b="0"/>
+              <a:t>PC -&gt; RPi -&gt; ESP32 (modelo global).</a:t>
+            </a:r>
+          </a:p>
+          <a:p>
+            <a:r>
+              <a:rPr sz="2800" b="1"/>
+              <a:t>2) Local: </a:t>
+            </a:r>
+            <a:r>
+              <a:rPr sz="2800" b="0"/>
+              <a:t>ESP32 publica features, RPi etiqueta y entrena.</a:t>
+            </a:r>
+          </a:p>
+          <a:p>
+            <a:r>
+              <a:rPr sz="2800" b="1"/>
+              <a:t>3) Bottom-Up: </a:t>
+            </a:r>
+            <a:r>
+              <a:rPr sz="2800" b="0"/>
+              <a:t>RPi reporta pesos, PC ejecuta FedAvg.</a:t>
+            </a:r>
+          </a:p>
+          <a:p>
+            <a:r>
+              <a:rPr sz="2800" b="0"/>
+              <a:t>Buffer N=30 muestras, 5 epocas, batch 8, Adam (lr=0.005).</a:t>
+            </a:r>
+          </a:p>
+          <a:p>
+            <a:r>
+              <a:rPr sz="2800" b="0"/>
+              <a:t>Modelo de amenazas explicito: confidencialidad, integridad y replay.</a:t>
+            </a:r>
+          </a:p>
+        </p:txBody>
+      </p:sp>
+      <p:sp>
+        <p:nvSpPr>
+          <p:cNvPr id="19" name="18 Resultados contenido"/>
+          <p:cNvSpPr>
+            <a:spLocks noGrp="1"/>
+          </p:cNvSpPr>
+          <p:nvPr>
+            <p:ph sz="quarter" idx="38"/>
+          </p:nvPr>
+        </p:nvSpPr>
+        <p:spPr>
+          <a:xfrm>
+            <a:off x="13393663" y="20594488"/>
+            <a:ext cx="11520000" cy="3340939"/>
+          </a:xfrm>
+        </p:spPr>
+        <p:txBody>
+          <a:bodyPr>
+            <a:normAutofit fontScale="85000" lnSpcReduction="15000"/>
+          </a:bodyPr>
+          <a:lstStyle/>
           <a:p>
             <a:pPr marL="285750" indent="-285750">
               <a:buFont typeface="Arial" panose="020B0604020202020204" pitchFamily="34" charset="0"/>
               <a:buChar char="-"/>
             </a:pPr>
             <a:r>
-              <a:rPr lang="es-CO"/>
-              <a:t>Construir un pipeline de 13 features de flujo y problema triclase (normal, mqtt_bruteforce, scan_A).</a:t>
-            </a:r>
-          </a:p>
+              <a:rPr sz="2800" b="1"/>
+              <a:t>Hallazgos clave (58 intentos sobre hardware):</a:t>
+            </a:r>
+          </a:p>
+          <a:p>
+            <a:r>
+              <a:rPr sz="2800" b="1"/>
+              <a:t>CNN_ASCON_FOG: </a:t>
+            </a:r>
+            <a:r>
+              <a:rPr sz="2800" b="0"/>
+              <a:t>acc 0.975, loss 0.091 (mejor variante).</a:t>
+            </a:r>
+          </a:p>
+          <a:p>
+            <a:r>
+              <a:rPr sz="2800" b="0"/>
+              <a:t>ASCON mejora la accuracy +3.2 pts vs PLAIN.</a:t>
+            </a:r>
+          </a:p>
+          <a:p>
+            <a:r>
+              <a:rPr sz="2800" b="0"/>
+              <a:t>Overhead temporal ASCON: 0.10-0.27% del ciclo FL.</a:t>
+            </a:r>
+          </a:p>
+          <a:p>
+            <a:r>
+              <a:rPr sz="2800" b="0"/>
+              <a:t>Overhead de tamano: +48% por mensaje (~1.07 KB).</a:t>
+            </a:r>
+          </a:p>
+          <a:p>
+            <a:r>
+              <a:rPr sz="2800" b="0"/>
+              <a:t>Convergencia &gt;0.90 en 5-10 rondas.</a:t>
+            </a:r>
+          </a:p>
+        </p:txBody>
+      </p:sp>
+      <p:sp>
+        <p:nvSpPr>
+          <p:cNvPr id="20" name="19 Conclusiones contenido"/>
+          <p:cNvSpPr>
+            <a:spLocks noGrp="1"/>
+          </p:cNvSpPr>
+          <p:nvPr>
+            <p:ph sz="quarter" idx="39"/>
+          </p:nvPr>
+        </p:nvSpPr>
+        <p:spPr/>
+        <p:txBody>
+          <a:bodyPr>
+            <a:normAutofit fontScale="92500" lnSpcReduction="10000"/>
+          </a:bodyPr>
+          <a:lstStyle/>
           <a:p>
             <a:pPr marL="285750" indent="-285750">
               <a:buFont typeface="Arial" panose="020B0604020202020204" pitchFamily="34" charset="0"/>
               <a:buChar char="-"/>
             </a:pPr>
             <a:r>
-              <a:rPr lang="es-CO"/>
-              <a:t>Comparar MLP, CNN-1D, Residual MLP y Tiny Transformer y exportar pesos al ESP32.</a:t>
-            </a:r>
-          </a:p>
-          <a:p>
-            <a:pPr marL="285750" indent="-285750">
-              <a:buFont typeface="Arial" panose="020B0604020202020204" pitchFamily="34" charset="0"/>
-              <a:buChar char="-"/>
-            </a:pPr>
-            <a:r>
-              <a:rPr lang="es-CO"/>
-              <a:t>Implementar HFL bidireccional con ASCON-128 y baseline sin cifrado para medir overhead.</a:t>
-            </a:r>
-          </a:p>
-          <a:p>
-            <a:pPr marL="285750" indent="-285750">
-              <a:buFont typeface="Arial" panose="020B0604020202020204" pitchFamily="34" charset="0"/>
-              <a:buChar char="-"/>
-            </a:pPr>
-            <a:r>
-              <a:rPr lang="es-CO"/>
-              <a:t>Evaluar variantes RN, CNN-1D y modo FOG (lider/peer) sobre hardware real.</a:t>
-            </a:r>
-          </a:p>
-        </p:txBody>
-      </p:sp>
-      <p:sp>
-        <p:nvSpPr>
-          <p:cNvPr id="17" name="16 Diseno contenido"/>
-          <p:cNvSpPr>
-            <a:spLocks noGrp="1"/>
-          </p:cNvSpPr>
-          <p:nvPr>
-            <p:ph sz="quarter" idx="36"/>
-          </p:nvPr>
-        </p:nvSpPr>
-        <p:spPr/>
-        <p:txBody>
-          <a:bodyPr>
-            <a:normAutofit fontScale="90000" lnSpcReduction="10000"/>
-          </a:bodyPr>
-          <a:lstStyle/>
-          <a:p>
-            <a:r>
-              <a:rPr lang="es-CO" b="1"/>
-              <a:t xml:space="preserve">Edge (ESP32-S3): </a:t>
-            </a:r>
-            <a:r>
-              <a:rPr lang="es-CO"/>
-              <a:t>genera/captura trafico MQTT, extrae 13 features de flujo y ejecuta inferencia TinyML del MLP (1.139 parametros, ~4.5 KB) o CNN-1D.</a:t>
-            </a:r>
-          </a:p>
-          <a:p>
-            <a:r>
-              <a:rPr lang="es-CO" b="1"/>
-              <a:t xml:space="preserve">Fog (Raspberry Pi 4): </a:t>
-            </a:r>
-            <a:r>
-              <a:rPr lang="es-CO"/>
-              <a:t>broker MQTT, etiquetado heuristico, buffer de 40 muestras, entrenamiento local (5 epocas, batch 8, Adam lr=0.005) y reenvio de pesos.</a:t>
-            </a:r>
-          </a:p>
-          <a:p>
-            <a:r>
-              <a:rPr lang="es-CO" b="1"/>
-              <a:t xml:space="preserve">Cloud (PC): </a:t>
-            </a:r>
-            <a:r>
-              <a:rPr lang="es-CO"/>
-              <a:t>FastAPI + FedAvg ponderado por muestras, dashboard analitico Chart.js.</a:t>
-            </a:r>
-          </a:p>
-          <a:p>
-            <a:r>
-              <a:rPr lang="es-CO" b="1"/>
-              <a:t xml:space="preserve">ASCON-128: </a:t>
-            </a:r>
-            <a:r>
-              <a:rPr lang="es-CO"/>
-              <a:t>AEAD (clave 128 b, nonce 128 b, tag 128 b) en C++ (ESP32) y Python (RPi/PC), interoperables. Envelope JSON {ct, tag, nonce} en Base64. Validacion de tag obligatoria.</a:t>
-            </a:r>
-          </a:p>
-          <a:p>
-            <a:r>
-              <a:rPr lang="es-CO" b="1"/>
-              <a:t xml:space="preserve">Modo FOG: </a:t>
-            </a:r>
-            <a:r>
-              <a:rPr lang="es-CO"/>
-              <a:t>una RPi lider hace FedAvg de gateways peers via MQTT (fog/weights, fog/global_model) y reporta al PC (/aggregate-from-fog).</a:t>
-            </a:r>
-          </a:p>
-          <a:p>
-            <a:r>
-              <a:rPr lang="es-CO" b="1"/>
-              <a:t xml:space="preserve">Variantes evaluadas: </a:t>
-            </a:r>
-            <a:r>
-              <a:rPr lang="es-CO"/>
-              <a:t>hfl_v7-RN (MLP+ASCON), hfl_v7-no-ascon-RN (baseline JSON plano), hfl_v7-CNN (CNN-1D, estandar y FOG).</a:t>
-            </a:r>
-          </a:p>
-        </p:txBody>
-      </p:sp>
-      <p:sp>
-        <p:nvSpPr>
-          <p:cNvPr id="18" name="17 Metodologia contenido"/>
-          <p:cNvSpPr>
-            <a:spLocks noGrp="1"/>
-          </p:cNvSpPr>
-          <p:nvPr>
-            <p:ph sz="quarter" idx="37"/>
-          </p:nvPr>
-        </p:nvSpPr>
-        <p:spPr/>
-        <p:txBody>
-          <a:bodyPr>
-            <a:normAutofit fontScale="92500" lnSpcReduction="10000"/>
-          </a:bodyPr>
-          <a:lstStyle/>
-          <a:p>
-            <a:r>
-              <a:rPr lang="es-CO"/>
-              <a:t>Investigacion experimental cuantitativa en seis fases: (1) construccion del pipeline de 13 features y triclase; (2) entrenamiento offline comparativo de MLP, CNN-1D, Residual MLP y Tiny Transformer; (3) implementacion del HFL bidireccional sobre ESP32 + RPi + PC; (4) integracion de ASCON-128 sobre los 4 canales (ESP32&lt;-&gt;RPi via MQTT, RPi&lt;-&gt;PC via HTTP); (5) baseline funcionalmente equivalente sin cifrado para aislar el costo de seguridad; (6) evaluacion de variantes RN, CNN-1D y modo FOG, con metricas de accuracy/loss, costo de comunicacion, tiempos de cifrado y duracion de ronda. Modelo de amenazas explicito: confidencialidad, integridad y replay; quedan fuera del alcance clientes bizantinos, ataques de canal lateral e inferencia de membresia.</a:t>
-            </a:r>
-            <a:endParaRPr lang="es-CO"/>
-          </a:p>
-        </p:txBody>
-      </p:sp>
-      <p:sp>
-        <p:nvSpPr>
-          <p:cNvPr id="19" name="18 Resultados contenido"/>
-          <p:cNvSpPr>
-            <a:spLocks noGrp="1"/>
-          </p:cNvSpPr>
-          <p:nvPr>
-            <p:ph sz="quarter" idx="38"/>
-          </p:nvPr>
-        </p:nvSpPr>
-        <p:spPr/>
-        <p:txBody>
-          <a:bodyPr>
-            <a:normAutofit fontScale="85000" lnSpcReduction="15000"/>
-          </a:bodyPr>
-          <a:lstStyle/>
-          <a:p>
-            <a:pPr marL="285750" indent="-285750">
-              <a:buFont typeface="Arial" panose="020B0604020202020204" pitchFamily="34" charset="0"/>
-              <a:buChar char="-"/>
-            </a:pPr>
-            <a:r>
-              <a:rPr lang="es-CO" b="1"/>
-              <a:t xml:space="preserve">Centralizado (techo): </a:t>
-            </a:r>
-            <a:r>
-              <a:rPr lang="es-CO"/>
-              <a:t>Random Forest 0.9994, SVM-RBF 0.9968 (no caben en MCU); Decision Tree 0.9987 (~15 KB); MLP propuesto ~4.5 KB.</a:t>
-            </a:r>
-          </a:p>
-          <a:p>
-            <a:pPr marL="285750" indent="-285750">
-              <a:buFont typeface="Arial" panose="020B0604020202020204" pitchFamily="34" charset="0"/>
-              <a:buChar char="-"/>
-            </a:pPr>
-            <a:r>
-              <a:rPr lang="es-CO" b="1"/>
-              <a:t xml:space="preserve">8 variantes en hardware (58 intentos): </a:t>
-            </a:r>
-            <a:r>
-              <a:rPr lang="es-CO"/>
-              <a:t>CNN_ASCON_FOG 0.9750 (mejor); CNN_ASCON_NoFOG 0.9604; RN_ASCON_FOG 0.9633; RN_ASCON_NoFOG 0.9381; CNN_PLAIN_FOG 0.9444; CNN_PLAIN_NoFOG 0.9389; RN_PLAIN_NoFOG 0.9298; RN_PLAIN_FOG 0.9000.</a:t>
-            </a:r>
-          </a:p>
-          <a:p>
-            <a:pPr marL="285750" indent="-285750">
-              <a:buFont typeface="Arial" panose="020B0604020202020204" pitchFamily="34" charset="0"/>
-              <a:buChar char="-"/>
-            </a:pPr>
-            <a:r>
-              <a:rPr lang="es-CO" b="1"/>
-              <a:t xml:space="preserve">ASCON mejora la accuracy: </a:t>
-            </a:r>
-            <a:r>
-              <a:rPr lang="es-CO"/>
-              <a:t>+3.2 pts promedio frente a PLAIN (0.9592 vs 0.9272). El tag autenticado actua como filtro implicito de mensajes corruptos.</a:t>
-            </a:r>
-          </a:p>
-          <a:p>
-            <a:pPr marL="285750" indent="-285750">
-              <a:buFont typeface="Arial" panose="020B0604020202020204" pitchFamily="34" charset="0"/>
-              <a:buChar char="-"/>
-            </a:pPr>
-            <a:r>
-              <a:rPr lang="es-CO" b="1"/>
-              <a:t xml:space="preserve">FOG con/sin ASCON: </a:t>
-            </a:r>
-            <a:r>
-              <a:rPr lang="es-CO"/>
-              <a:t>FOG mejora CNN (+1.5 pts ASCON, +0.6 pts PLAIN) y RN+ASCON (+2.5 pts), pero degrada RN_PLAIN_FOG (-3 pts). La integridad de canal habilita la pre-agregacion.</a:t>
-            </a:r>
-          </a:p>
-          <a:p>
-            <a:pPr marL="285750" indent="-285750">
-              <a:buFont typeface="Arial" panose="020B0604020202020204" pitchFamily="34" charset="0"/>
-              <a:buChar char="-"/>
-            </a:pPr>
-            <a:r>
-              <a:rPr lang="es-CO" b="1"/>
-              <a:t xml:space="preserve">Privacidad: </a:t>
-            </a:r>
-            <a:r>
-              <a:rPr lang="es-CO"/>
-              <a:t>se comparten solo 163 parametros (~652 B) por ronda en lugar de ~13.3 M de valores crudos (reduccion &gt;99.99%).</a:t>
-            </a:r>
-          </a:p>
-          <a:p>
-            <a:pPr marL="285750" indent="-285750">
-              <a:buFont typeface="Arial" panose="020B0604020202020204" pitchFamily="34" charset="0"/>
-              <a:buChar char="-"/>
-            </a:pPr>
-            <a:r>
-              <a:rPr lang="es-CO" b="1"/>
-              <a:t xml:space="preserve">Overhead ASCON-128: </a:t>
-            </a:r>
-            <a:r>
-              <a:rPr lang="es-CO"/>
-              <a:t>p95 ~4.5 ms en ESP32 (C++) y 25-50 ms en PC (Python). Total 0.10-0.27% del ciclo FL. Tamano: +48% por mensaje (~1.07 KB absolutos).</a:t>
-            </a:r>
-          </a:p>
-        </p:txBody>
-      </p:sp>
-      <p:sp>
-        <p:nvSpPr>
-          <p:cNvPr id="20" name="19 Conclusiones contenido"/>
-          <p:cNvSpPr>
-            <a:spLocks noGrp="1"/>
-          </p:cNvSpPr>
-          <p:nvPr>
-            <p:ph sz="quarter" idx="39"/>
-          </p:nvPr>
-        </p:nvSpPr>
-        <p:spPr/>
-        <p:txBody>
-          <a:bodyPr>
-            <a:normAutofit fontScale="92500" lnSpcReduction="10000"/>
-          </a:bodyPr>
-          <a:lstStyle/>
-          <a:p>
-            <a:pPr marL="285750" indent="-285750">
-              <a:buFont typeface="Arial" panose="020B0604020202020204" pitchFamily="34" charset="0"/>
-              <a:buChar char="-"/>
-            </a:pPr>
-            <a:r>
-              <a:rPr lang="es-CO"/>
-              <a:t>TinyML viable: MLP de 4.5 KB y CNN-1D federada en ESP32-S3 alcanzan acc 0.93-0.97 (CNN_ASCON_FOG: 0.975) sobre 58 intentos en hardware real.</a:t>
-            </a:r>
-          </a:p>
-          <a:p>
-            <a:pPr marL="285750" indent="-285750">
-              <a:buFont typeface="Arial" panose="020B0604020202020204" pitchFamily="34" charset="0"/>
-              <a:buChar char="-"/>
-            </a:pPr>
-            <a:r>
-              <a:rPr lang="es-CO"/>
-              <a:t>HFL bidireccional reduce &gt;99.99% el intercambio de datos sensibles con una penalizacion de 2-3 puntos en la mejor variante (CNN_ASCON_FOG vs Random Forest).</a:t>
-            </a:r>
-          </a:p>
-          <a:p>
-            <a:pPr marL="285750" indent="-285750">
-              <a:buFont typeface="Arial" panose="020B0604020202020204" pitchFamily="34" charset="0"/>
-              <a:buChar char="-"/>
-            </a:pPr>
-            <a:r>
-              <a:rPr lang="es-CO"/>
-              <a:t>ASCON-128 no solo no degrada: mejora la accuracy +3.2 pts vs PLAIN (filtrado implicito de mensajes corruptos). Overhead: 0.10-0.27% del ciclo y +48% por mensaje.</a:t>
-            </a:r>
-          </a:p>
-          <a:p>
-            <a:pPr marL="285750" indent="-285750">
-              <a:buFont typeface="Arial" panose="020B0604020202020204" pitchFamily="34" charset="0"/>
-              <a:buChar char="-"/>
-            </a:pPr>
-            <a:r>
-              <a:rPr lang="es-CO"/>
-              <a:t>FOG con ASCON gana (+1.5 a +2.5 pts), pero FOG sin ASCON degrada RN (-3 pts): la integridad de canal es condicion habilitante de la pre-agregacion fog.</a:t>
-            </a:r>
-          </a:p>
-          <a:p>
-            <a:pPr marL="285750" indent="-285750">
-              <a:buFont typeface="Arial" panose="020B0604020202020204" pitchFamily="34" charset="0"/>
-              <a:buChar char="-"/>
-            </a:pPr>
-            <a:r>
-              <a:rPr lang="es-CO"/>
-              <a:t>Trabajos futuros: robustez bizantina (Krum/FLTrust), cuantizacion INT8, contramedidas SCA sobre ASCON, datasets reales (CICIoT2023, TON_IoT) y differential privacy.</a:t>
-            </a:r>
-          </a:p>
-        </p:txBody>
-      </p:sp>
+              <a:rPr sz="2800" b="1"/>
+              <a:t>TinyML viable: </a:t>
+            </a:r>
+            <a:r>
+              <a:rPr sz="2800" b="0"/>
+              <a:t>0.93-0.97 acc en ESP32-S3.</a:t>
+            </a:r>
+          </a:p>
+          <a:p>
+            <a:r>
+              <a:rPr sz="2800" b="0"/>
+              <a:t>HFL reduce &gt;99.99% el intercambio de datos sensibles.</a:t>
+            </a:r>
+          </a:p>
+          <a:p>
+            <a:r>
+              <a:rPr sz="2800" b="0"/>
+              <a:t>ASCON-128 mejora la accuracy y filtra mensajes corruptos.</a:t>
+            </a:r>
+          </a:p>
+          <a:p>
+            <a:r>
+              <a:rPr sz="2800" b="0"/>
+              <a:t>FOG con ASCON gana; FOG sin ASCON degrada RN (-3 pts).</a:t>
+            </a:r>
+          </a:p>
+          <a:p>
+            <a:r>
+              <a:rPr sz="2800" b="1"/>
+              <a:t>Trabajo futuro: </a:t>
+            </a:r>
+            <a:r>
+              <a:rPr sz="2800" b="0"/>
+              <a:t>robustez bizantina, cuantizacion INT8, datasets reales.</a:t>
+            </a:r>
+          </a:p>
+        </p:txBody>
+      </p:sp>
+      <p:pic>
+        <p:nvPicPr>
+          <p:cNvPr id="21" name="Picture 20" descr="hfl_v7_architecture.png"/>
+          <p:cNvPicPr>
+            <a:picLocks noChangeAspect="1"/>
+          </p:cNvPicPr>
+          <p:nvPr/>
+        </p:nvPicPr>
+        <p:blipFill>
+          <a:blip r:embed="rId2"/>
+          <a:stretch>
+            <a:fillRect/>
+          </a:stretch>
+        </p:blipFill>
+        <p:spPr>
+          <a:xfrm>
+            <a:off x="16318561" y="15117307"/>
+            <a:ext cx="5670204" cy="3657600"/>
+          </a:xfrm>
+          <a:prstGeom prst="rect">
+            <a:avLst/>
+          </a:prstGeom>
+        </p:spPr>
+      </p:pic>
+      <p:pic>
+        <p:nvPicPr>
+          <p:cNvPr id="22" name="Picture 21" descr="hfl_v7_bidirectional_flow.png"/>
+          <p:cNvPicPr>
+            <a:picLocks noChangeAspect="1"/>
+          </p:cNvPicPr>
+          <p:nvPr/>
+        </p:nvPicPr>
+        <p:blipFill>
+          <a:blip r:embed="rId3"/>
+          <a:stretch>
+            <a:fillRect/>
+          </a:stretch>
+        </p:blipFill>
+        <p:spPr>
+          <a:xfrm>
+            <a:off x="2900433" y="28529049"/>
+            <a:ext cx="7015627" cy="5943600"/>
+          </a:xfrm>
+          <a:prstGeom prst="rect">
+            <a:avLst/>
+          </a:prstGeom>
+        </p:spPr>
+      </p:pic>
+      <p:pic>
+        <p:nvPicPr>
+          <p:cNvPr id="23" name="Picture 22" descr="global_accuracy_loss.png"/>
+          <p:cNvPicPr>
+            <a:picLocks noChangeAspect="1"/>
+          </p:cNvPicPr>
+          <p:nvPr/>
+        </p:nvPicPr>
+        <p:blipFill>
+          <a:blip r:embed="rId4"/>
+          <a:stretch>
+            <a:fillRect/>
+          </a:stretch>
+        </p:blipFill>
+        <p:spPr>
+          <a:xfrm>
+            <a:off x="14516418" y="24118307"/>
+            <a:ext cx="9274489" cy="3657600"/>
+          </a:xfrm>
+          <a:prstGeom prst="rect">
+            <a:avLst/>
+          </a:prstGeom>
+        </p:spPr>
+      </p:pic>
     </p:spTree>
     <p:extLst>
       <p:ext uri="{BB962C8B-B14F-4D97-AF65-F5344CB8AC3E}">

</xml_diff>